<commit_message>
Fix awkward expressions in hackathon presentation
Replace unnatural phrasing with direct, clean Romanian throughout
all slides.

https://claude.ai/code/session_016XVn5Sgv7ziqB9u1ZeN5JP
</commit_message>
<xml_diff>
--- a/Prezentare_Electron_2026.pptx
+++ b/Prezentare_Electron_2026.pptx
@@ -4006,7 +4006,7 @@
                 </a:solidFill>
                 <a:latin typeface="Segoe UI"/>
               </a:rPr>
-              <a:t>Am vazut 'AI &amp; ML' in titlu si pur si simplu n-am putut sa dam pass.</a:t>
+              <a:t>Ne-am inscris de cum am vazut subiectele. Nu era nevoie de mai multa deliberare.</a:t>
             </a:r>
           </a:p>
           <a:p>
@@ -4054,8 +4054,8 @@
                 </a:solidFill>
                 <a:latin typeface="Segoe UI"/>
               </a:rPr>
-              <a:t>Probleme cu rețele neurale, clasificatoare de imagini, atacuri adversariale —
-exact genul de lucruri pe care le citești în papers și vrei să le atingi cu mâna.</a:t>
+              <a:t>Retele neurale, clasificatoare de imagini, atacuri adversariale —
+subiecte studiate teoretic, acum de rezolvat practic, in timp limitat.</a:t>
             </a:r>
           </a:p>
           <a:p>
@@ -4087,7 +4087,7 @@
                 </a:solidFill>
                 <a:latin typeface="Segoe UI"/>
               </a:rPr>
-              <a:t>🕐  Managementul timpului ca skill real</a:t>
+              <a:t>🕐  O lectie despre gestionarea timpului</a:t>
             </a:r>
           </a:p>
           <a:p>
@@ -4103,7 +4103,7 @@
                 </a:solidFill>
                 <a:latin typeface="Segoe UI"/>
               </a:rPr>
-              <a:t>Știam că va fi intens. Voiam să vedem cât de bine ne descurcăm sub presiune.</a:t>
+              <a:t>Stiam ca va fi intens. Am vrut sa vedem cum ne descurcam cand timpul e limitat cu adevarat.</a:t>
             </a:r>
           </a:p>
         </p:txBody>
@@ -7729,8 +7729,8 @@
                 </a:solidFill>
                 <a:latin typeface="Segoe UI"/>
               </a:rPr>
-              <a:t>Un patch mic de 32×32 poate complet păcăli un clasificator de 50 de clase.
-Modelele nu 'văd' cum vedem noi — asta e fascinant și îngrijorător în același timp.</a:t>
+              <a:t>Un patch mic de 32x32 este suficient pentru a pacali un clasificator de 50 de clase.
+Modelele nu percep imaginile asa cum o facem noi — si asta are consecinte reale.</a:t>
             </a:r>
           </a:p>
         </p:txBody>
@@ -7957,8 +7957,8 @@
                 </a:solidFill>
                 <a:latin typeface="Segoe UI"/>
               </a:rPr>
-              <a:t>Computer Vision + Security a fost preferata — faptul că poți 'ataca' rețele
-neurale cu imagini pare magie neagră la prima vedere.</a:t>
+              <a:t>Computer Vision combinat cu Security a fost cel mai interesant pentru noi —
+un domeniu activ de cercetare, cu aplicatii directe in sisteme reale.</a:t>
             </a:r>
           </a:p>
         </p:txBody>
@@ -8140,7 +8140,7 @@
                 </a:solidFill>
                 <a:latin typeface="Segoe UI"/>
               </a:rPr>
-              <a:t>(spoiler: nu e despre ML)</a:t>
+              <a:t>Lectii care raman dupa ce uiti codul</a:t>
             </a:r>
           </a:p>
         </p:txBody>
@@ -8288,7 +8288,7 @@
                 </a:solidFill>
                 <a:latin typeface="Segoe UI"/>
               </a:rPr>
-              <a:t>Prima oră: explorezi. Ora 2+: construiești. Știi când să oprești rabbit holes.</a:t>
+              <a:t>Prima ora: intelegi problema. De la ora 2: construiesti. Fiecare deraiere costa timp real.</a:t>
             </a:r>
           </a:p>
         </p:txBody>
@@ -8401,7 +8401,7 @@
                 </a:solidFill>
                 <a:latin typeface="Segoe UI"/>
               </a:rPr>
-              <a:t>Focus &gt; Perfecțiune</a:t>
+              <a:t>Focus inainte de perfectiune</a:t>
             </a:r>
           </a:p>
         </p:txBody>
@@ -8436,7 +8436,7 @@
                 </a:solidFill>
                 <a:latin typeface="Segoe UI"/>
               </a:rPr>
-              <a:t>Un submit mediocru acum bate un submit perfect mâine. Feedback rapid contează.</a:t>
+              <a:t>O solutie functionala acum este mai valoroasa decat una perfecta prea tarziu.</a:t>
             </a:r>
           </a:p>
         </p:txBody>
@@ -8549,7 +8549,7 @@
                 </a:solidFill>
                 <a:latin typeface="Segoe UI"/>
               </a:rPr>
-              <a:t>Comunicarea salvează</a:t>
+              <a:t>Comunicarea conteaza</a:t>
             </a:r>
           </a:p>
         </p:txBody>
@@ -8584,7 +8584,7 @@
                 </a:solidFill>
                 <a:latin typeface="Segoe UI"/>
               </a:rPr>
-              <a:t>Dacă doi oameni lucrează pe același lucru fără să știe → dublu timp pierdut.</a:t>
+              <a:t>Doi oameni care lucreaza pe acelasi lucru fara sa stie inseamna timp dublat pierdut.</a:t>
             </a:r>
           </a:p>
         </p:txBody>

</xml_diff>